<commit_message>
Slides: set title and author in the file properties; small layout fixes
Co-Authored-By: Claude Opus 5.5 <noreply@anthropic.com>
Claude-Session: https://claude.ai/code/session_01FweA52RNaUuQsaYrfNv198
</commit_message>
<xml_diff>
--- a/Project 3 Presentation.pptx
+++ b/Project 3 Presentation.pptx
@@ -7947,7 +7947,7 @@
                 </a:solidFill>
                 <a:latin typeface="Calibri"/>
               </a:rPr>
-              <a:t>A grid search tried C = 1, 10, 100 and 1,000 with 100-fold cross-validation: 400 fits, about four minutes on a 32-thread computer.</a:t>
+              <a:t>A grid search tried C = 1, 10, 100 and 1,000 with 100-fold cross-validation: 400 fits, about four minutes on a computer with 32 threads.</a:t>
             </a:r>
           </a:p>
           <a:p>
@@ -12669,7 +12669,7 @@
         <p:spPr>
           <a:xfrm>
             <a:off x="7269480" y="1463040"/>
-            <a:ext cx="4389120" cy="2057400"/>
+            <a:ext cx="4389120" cy="1783080"/>
           </a:xfrm>
           <a:prstGeom prst="rect">
             <a:avLst/>
@@ -12696,7 +12696,7 @@
         <p:spPr>
           <a:xfrm>
             <a:off x="7498079" y="1600200"/>
-            <a:ext cx="3977639" cy="2103120"/>
+            <a:ext cx="3977639" cy="1645920"/>
           </a:xfrm>
           <a:prstGeom prst="rect">
             <a:avLst/>

</xml_diff>

<commit_message>
Slide and README wording fixes; Hamming loss to three decimals
Co-Authored-By: Claude Opus 5.5 <noreply@anthropic.com>
Claude-Session: https://claude.ai/code/session_01FweA52RNaUuQsaYrfNv198
</commit_message>
<xml_diff>
--- a/Project 3 Presentation.pptx
+++ b/Project 3 Presentation.pptx
@@ -121,26 +121,26 @@
   <p:extLst>
     <p:ext uri="{521415D9-36F7-43E2-AB2F-B90AF26B5E84}">
       <p14:sectionLst xmlns:p14="http://schemas.microsoft.com/office/powerpoint/2010/main">
-        <p14:section name="Introduction" id="{18690755-567b-a9af-e302-c7742fc68496}">
+        <p14:section name="Introduction" id="{c05733db-4c10-fd71-50a3-5cb6f4a2d1b4}">
           <p14:sldIdLst>
             <p14:sldId id="256"/>
             <p14:sldId id="257"/>
           </p14:sldIdLst>
         </p14:section>
-        <p14:section name="Data" id="{450e878d-b51b-ef43-6edd-9293f13deb28}">
+        <p14:section name="Data" id="{6b797207-517d-49f6-1487-6ea770a63bbb}">
           <p14:sldIdLst>
             <p14:sldId id="258"/>
             <p14:sldId id="259"/>
             <p14:sldId id="260"/>
           </p14:sldIdLst>
         </p14:section>
-        <p14:section name="Method" id="{e8fec15b-e754-caee-ee0f-58d6d2d5b23b}">
+        <p14:section name="Method" id="{6771bbeb-6c4d-0708-7255-e223bde6a87f}">
           <p14:sldIdLst>
             <p14:sldId id="261"/>
             <p14:sldId id="262"/>
           </p14:sldIdLst>
         </p14:section>
-        <p14:section name="Results" id="{2728c555-f627-681c-2ba1-29f21ba9f774}">
+        <p14:section name="Results" id="{ff505cab-a91b-491e-ab0c-335db3f85f54}">
           <p14:sldIdLst>
             <p14:sldId id="263"/>
             <p14:sldId id="264"/>
@@ -150,7 +150,7 @@
             <p14:sldId id="268"/>
           </p14:sldIdLst>
         </p14:section>
-        <p14:section name="Lessons" id="{69494ebd-154d-f96a-5213-855f27147ac3}">
+        <p14:section name="Lessons" id="{513c3f98-b450-8652-9697-65e05a24591e}">
           <p14:sldIdLst>
             <p14:sldId id="269"/>
             <p14:sldId id="270"/>
@@ -987,40 +987,40 @@
                 <c:formatCode>General</c:formatCode>
                 <c:ptCount val="12"/>
                 <c:pt idx="0">
-                  <c:v>48.5</c:v>
+                  <c:v>48.49621094740401</c:v>
                 </c:pt>
                 <c:pt idx="1">
-                  <c:v>47.76</c:v>
+                  <c:v>47.7634260172221</c:v>
                 </c:pt>
                 <c:pt idx="2">
-                  <c:v>45.94</c:v>
+                  <c:v>45.93669887596135</c:v>
                 </c:pt>
                 <c:pt idx="3">
-                  <c:v>45.9</c:v>
+                  <c:v>45.897258923289286</c:v>
                 </c:pt>
                 <c:pt idx="4">
-                  <c:v>45.78</c:v>
+                  <c:v>45.77959639781765</c:v>
                 </c:pt>
                 <c:pt idx="5">
-                  <c:v>45.73</c:v>
+                  <c:v>45.72832445934398</c:v>
                 </c:pt>
                 <c:pt idx="6">
-                  <c:v>43.11</c:v>
+                  <c:v>43.10631884384596</c:v>
                 </c:pt>
                 <c:pt idx="7">
-                  <c:v>42.68</c:v>
+                  <c:v>42.677479787024254</c:v>
                 </c:pt>
                 <c:pt idx="8">
-                  <c:v>41.09</c:v>
+                  <c:v>41.08558469729836</c:v>
                 </c:pt>
                 <c:pt idx="9">
-                  <c:v>24.22</c:v>
+                  <c:v>24.218431604548744</c:v>
                 </c:pt>
                 <c:pt idx="10">
-                  <c:v>23.17</c:v>
+                  <c:v>23.167356865838425</c:v>
                 </c:pt>
                 <c:pt idx="11">
-                  <c:v>2.57</c:v>
+                  <c:v>2.5727761031448666</c:v>
                 </c:pt>
               </c:numCache>
             </c:numRef>
@@ -1223,7 +1223,7 @@
           </c:spPr>
           <c:invertIfNegative val="0"/>
           <c:dLbls>
-            <c:numFmt formatCode="0.00%" sourceLinked="0"/>
+            <c:numFmt formatCode="0.000%" sourceLinked="0"/>
             <c:txPr>
               <a:bodyPr/>
               <a:lstStyle/>
@@ -1431,47 +1431,47 @@
                 <c:formatCode>General</c:formatCode>
                 <c:ptCount val="12"/>
                 <c:pt idx="0">
-                  <c:v>0.011899999999999999</c:v>
+                  <c:v>0.011855649773220272</c:v>
                 </c:pt>
                 <c:pt idx="1">
-                  <c:v>0.0102</c:v>
+                  <c:v>0.010175507789390652</c:v>
                 </c:pt>
                 <c:pt idx="2">
-                  <c:v>0.010700000000000001</c:v>
+                  <c:v>0.010733583119700256</c:v>
                 </c:pt>
                 <c:pt idx="3">
-                  <c:v>0.0108</c:v>
+                  <c:v>0.010755275093669888</c:v>
                 </c:pt>
                 <c:pt idx="4">
-                  <c:v>0.0108</c:v>
+                  <c:v>0.010755275093669888</c:v>
                 </c:pt>
                 <c:pt idx="5">
-                  <c:v>0.0102</c:v>
+                  <c:v>0.010228751725497929</c:v>
                 </c:pt>
                 <c:pt idx="6">
-                  <c:v>0.0141</c:v>
+                  <c:v>0.014109643068428318</c:v>
                 </c:pt>
                 <c:pt idx="7">
-                  <c:v>0.017</c:v>
+                  <c:v>0.01699270360875567</c:v>
                 </c:pt>
                 <c:pt idx="8">
-                  <c:v>0.0109</c:v>
+                  <c:v>0.010932754880694144</c:v>
                 </c:pt>
                 <c:pt idx="9">
-                  <c:v>0.014199999999999999</c:v>
+                  <c:v>0.0142358509169789</c:v>
                 </c:pt>
                 <c:pt idx="10">
-                  <c:v>0.013500000000000002</c:v>
+                  <c:v>0.013512127785446658</c:v>
                 </c:pt>
                 <c:pt idx="11">
-                  <c:v>0.031400000000000004</c:v>
+                  <c:v>0.03140800631039243</c:v>
                 </c:pt>
               </c:numCache>
             </c:numRef>
           </c:val>
         </c:ser>
         <c:dLbls>
-          <c:numFmt formatCode="0.00%" sourceLinked="0"/>
+          <c:numFmt formatCode="0.000%" sourceLinked="0"/>
           <c:txPr>
             <a:bodyPr/>
             <a:lstStyle/>
@@ -1543,7 +1543,7 @@
         <c:axId val="2094734552"/>
         <c:scaling>
           <c:orientation val="minMax"/>
-          <c:max val="0.038"/>
+          <c:max val="0.04"/>
           <c:min val="0"/>
         </c:scaling>
         <c:delete val="1"/>
@@ -2405,7 +2405,7 @@
                 </a:solidFill>
                 <a:latin typeface="+mn-lt"/>
               </a:rPr>
-              <a:t>The eight most common tags</a:t>
+              <a:t>The eight most common tags overall</a:t>
             </a:r>
           </a:p>
         </c:rich>
@@ -5418,7 +5418,7 @@
           <a:spcPct val="20000"/>
         </a:spcBef>
         <a:buFont typeface="Arial" pitchFamily="34" charset="0"/>
-        <a:buChar char="–"/>
+        <a:buChar char="•"/>
         <a:defRPr sz="2800" kern="1200">
           <a:solidFill>
             <a:schemeClr val="tx1"/>
@@ -5448,7 +5448,7 @@
           <a:spcPct val="20000"/>
         </a:spcBef>
         <a:buFont typeface="Arial" pitchFamily="34" charset="0"/>
-        <a:buChar char="–"/>
+        <a:buChar char="•"/>
         <a:defRPr sz="2000" kern="1200">
           <a:solidFill>
             <a:schemeClr val="tx1"/>
@@ -6529,7 +6529,7 @@
                   <a:schemeClr val="tx1"/>
                 </a:solidFill>
               </a:rPr>
-              <a:t>Usually right, but it missed over half the tags</a:t>
+              <a:t>Most of its guesses were right, but it missed over half the tags</a:t>
             </a:r>
             <a:endParaRPr lang="en-US" sz="3000" dirty="0"/>
           </a:p>
@@ -12391,7 +12391,7 @@
       </p:sp>
       <p:sp>
         <p:nvSpPr>
-          <p:cNvPr id="19" name="chip cc"/>
+          <p:cNvPr id="19" name="chip CC"/>
           <p:cNvSpPr/>
           <p:nvPr/>
         </p:nvSpPr>
@@ -12423,7 +12423,7 @@
                   <a:schemeClr val="accent5"/>
                 </a:solidFill>
               </a:rPr>
-              <a:t>cc</a:t>
+              <a:t>CC</a:t>
             </a:r>
             <a:endParaRPr lang="en-US" sz="1500" dirty="0"/>
           </a:p>
@@ -12597,7 +12597,7 @@
         <p:spPr>
           <a:xfrm>
             <a:off x="548640" y="5486400"/>
-            <a:ext cx="5486400" cy="777240"/>
+            <a:ext cx="5486400" cy="868680"/>
           </a:xfrm>
           <a:prstGeom prst="rect">
             <a:avLst/>
@@ -12618,7 +12618,7 @@
                   <a:schemeClr val="tx1"/>
                 </a:solidFill>
               </a:rPr>
-              <a:t>This is probably part of why these three tags scored lowest. The fix: match tag names in any case before removing punctuation, and let TF-IDF keep one-letter words.</a:t>
+              <a:t>This is probably part of why these three scored lowest of the language tags. To fix it, I would match tag names in any case before removing punctuation, and let TF-IDF keep one-letter words.</a:t>
             </a:r>
             <a:endParaRPr lang="en-US" sz="1400" dirty="0"/>
           </a:p>
@@ -12750,45 +12750,7 @@
       </p:sp>
       <p:sp>
         <p:nvSpPr>
-          <p:cNvPr id="3" name="Text 0"/>
-          <p:cNvSpPr/>
-          <p:nvPr>
-            <p:ph idx="101" type="body" hasCustomPrompt="1"/>
-          </p:nvPr>
-        </p:nvSpPr>
-        <p:spPr>
-          <a:xfrm>
-            <a:off x="548640" y="987552"/>
-            <a:ext cx="11064240" cy="411480"/>
-          </a:xfrm>
-          <a:prstGeom prst="rect">
-            <a:avLst/>
-          </a:prstGeom>
-          <a:noFill/>
-          <a:ln/>
-        </p:spPr>
-        <p:txBody>
-          <a:bodyPr wrap="square" lIns="0" tIns="0" rIns="0" bIns="0" rtlCol="0" anchor="ctr"/>
-          <a:lstStyle/>
-          <a:p>
-            <a:pPr algn="l" indent="0" marL="0">
-              <a:buNone/>
-            </a:pPr>
-            <a:r>
-              <a:rPr lang="en-US" sz="1600" dirty="0">
-                <a:solidFill>
-                  <a:schemeClr val="bg2"/>
-                </a:solidFill>
-              </a:rPr>
-              <a:t>Five things I would do differently, from the results above</a:t>
-            </a:r>
-            <a:endParaRPr lang="en-US" sz="1600" dirty="0"/>
-          </a:p>
-        </p:txBody>
-      </p:sp>
-      <p:sp>
-        <p:nvSpPr>
-          <p:cNvPr id="4" name="change Use the question body"/>
+          <p:cNvPr id="3" name="change Use the question body"/>
           <p:cNvSpPr/>
           <p:nvPr/>
         </p:nvSpPr>
@@ -12812,7 +12774,7 @@
       </p:sp>
       <p:sp>
         <p:nvSpPr>
-          <p:cNvPr id="5" name="icon circle book"/>
+          <p:cNvPr id="4" name="icon circle book"/>
           <p:cNvSpPr/>
           <p:nvPr/>
         </p:nvSpPr>
@@ -12832,7 +12794,7 @@
       </p:sp>
       <p:pic>
         <p:nvPicPr>
-          <p:cNvPr id="6" name="icon book" descr="/tmp/claude-0/-home-claude/8a3a1460-c291-5da5-a3bd-e15a8fc25c88/scratchpad/deck3/icons/book.png">    </p:cNvPr>
+          <p:cNvPr id="5" name="icon book" descr="Book icon">    </p:cNvPr>
           <p:cNvPicPr>
             <a:picLocks noChangeAspect="1"/>
           </p:cNvPicPr>
@@ -12856,14 +12818,50 @@
       </p:pic>
       <p:sp>
         <p:nvSpPr>
+          <p:cNvPr id="6" name="Text 3"/>
+          <p:cNvSpPr txBox="1"/>
+          <p:nvPr/>
+        </p:nvSpPr>
+        <p:spPr>
+          <a:xfrm>
+            <a:off x="1554480" y="1965960"/>
+            <a:ext cx="2331720" cy="548640"/>
+          </a:xfrm>
+          <a:prstGeom prst="rect">
+            <a:avLst/>
+          </a:prstGeom>
+          <a:noFill/>
+          <a:ln/>
+        </p:spPr>
+        <p:txBody>
+          <a:bodyPr wrap="square" lIns="0" tIns="0" rIns="0" bIns="0" rtlCol="0" anchor="ctr"/>
+          <a:lstStyle/>
+          <a:p>
+            <a:pPr indent="0" marL="0">
+              <a:buNone/>
+            </a:pPr>
+            <a:r>
+              <a:rPr lang="en-US" sz="1600" b="1" dirty="0">
+                <a:solidFill>
+                  <a:schemeClr val="bg1"/>
+                </a:solidFill>
+              </a:rPr>
+              <a:t>Use the question body</a:t>
+            </a:r>
+            <a:endParaRPr lang="en-US" sz="1600" dirty="0"/>
+          </a:p>
+        </p:txBody>
+      </p:sp>
+      <p:sp>
+        <p:nvSpPr>
           <p:cNvPr id="7" name="Text 4"/>
           <p:cNvSpPr txBox="1"/>
           <p:nvPr/>
         </p:nvSpPr>
         <p:spPr>
           <a:xfrm>
-            <a:off x="1554480" y="1965960"/>
-            <a:ext cx="2331720" cy="548640"/>
+            <a:off x="777240" y="2651760"/>
+            <a:ext cx="3063240" cy="1005840"/>
           </a:xfrm>
           <a:prstGeom prst="rect">
             <a:avLst/>
@@ -12872,49 +12870,13 @@
           <a:ln/>
         </p:spPr>
         <p:txBody>
-          <a:bodyPr wrap="square" lIns="0" tIns="0" rIns="0" bIns="0" rtlCol="0" anchor="ctr"/>
+          <a:bodyPr wrap="square" lIns="0" tIns="0" rIns="0" bIns="0" rtlCol="0" anchor="t"/>
           <a:lstStyle/>
           <a:p>
             <a:pPr indent="0" marL="0">
               <a:buNone/>
             </a:pPr>
             <a:r>
-              <a:rPr lang="en-US" sz="1600" b="1" dirty="0">
-                <a:solidFill>
-                  <a:schemeClr val="bg1"/>
-                </a:solidFill>
-              </a:rPr>
-              <a:t>Use the question body</a:t>
-            </a:r>
-            <a:endParaRPr lang="en-US" sz="1600" dirty="0"/>
-          </a:p>
-        </p:txBody>
-      </p:sp>
-      <p:sp>
-        <p:nvSpPr>
-          <p:cNvPr id="8" name="Text 5"/>
-          <p:cNvSpPr txBox="1"/>
-          <p:nvPr/>
-        </p:nvSpPr>
-        <p:spPr>
-          <a:xfrm>
-            <a:off x="777240" y="2651760"/>
-            <a:ext cx="3063240" cy="1005840"/>
-          </a:xfrm>
-          <a:prstGeom prst="rect">
-            <a:avLst/>
-          </a:prstGeom>
-          <a:noFill/>
-          <a:ln/>
-        </p:spPr>
-        <p:txBody>
-          <a:bodyPr wrap="square" lIns="0" tIns="0" rIns="0" bIns="0" rtlCol="0" anchor="t"/>
-          <a:lstStyle/>
-          <a:p>
-            <a:pPr indent="0" marL="0">
-              <a:buNone/>
-            </a:pPr>
-            <a:r>
               <a:rPr lang="en-US" sz="1400" dirty="0">
                 <a:solidFill>
                   <a:schemeClr val="bg2"/>
@@ -12928,7 +12890,7 @@
       </p:sp>
       <p:sp>
         <p:nvSpPr>
-          <p:cNvPr id="9" name="change Fix the cleanup"/>
+          <p:cNvPr id="8" name="change Fix the cleanup"/>
           <p:cNvSpPr/>
           <p:nvPr/>
         </p:nvSpPr>
@@ -12952,7 +12914,7 @@
       </p:sp>
       <p:sp>
         <p:nvSpPr>
-          <p:cNvPr id="10" name="icon circle broom"/>
+          <p:cNvPr id="9" name="icon circle broom"/>
           <p:cNvSpPr/>
           <p:nvPr/>
         </p:nvSpPr>
@@ -12972,7 +12934,7 @@
       </p:sp>
       <p:pic>
         <p:nvPicPr>
-          <p:cNvPr id="11" name="icon broom" descr="/tmp/claude-0/-home-claude/8a3a1460-c291-5da5-a3bd-e15a8fc25c88/scratchpad/deck3/icons/broom.png">    </p:cNvPr>
+          <p:cNvPr id="10" name="icon broom" descr="Broom icon">    </p:cNvPr>
           <p:cNvPicPr>
             <a:picLocks noChangeAspect="1"/>
           </p:cNvPicPr>
@@ -12996,14 +12958,50 @@
       </p:pic>
       <p:sp>
         <p:nvSpPr>
+          <p:cNvPr id="11" name="Text 7"/>
+          <p:cNvSpPr txBox="1"/>
+          <p:nvPr/>
+        </p:nvSpPr>
+        <p:spPr>
+          <a:xfrm>
+            <a:off x="5326380" y="1965960"/>
+            <a:ext cx="2331720" cy="548640"/>
+          </a:xfrm>
+          <a:prstGeom prst="rect">
+            <a:avLst/>
+          </a:prstGeom>
+          <a:noFill/>
+          <a:ln/>
+        </p:spPr>
+        <p:txBody>
+          <a:bodyPr wrap="square" lIns="0" tIns="0" rIns="0" bIns="0" rtlCol="0" anchor="ctr"/>
+          <a:lstStyle/>
+          <a:p>
+            <a:pPr indent="0" marL="0">
+              <a:buNone/>
+            </a:pPr>
+            <a:r>
+              <a:rPr lang="en-US" sz="1600" b="1" dirty="0">
+                <a:solidFill>
+                  <a:schemeClr val="bg1"/>
+                </a:solidFill>
+              </a:rPr>
+              <a:t>Fix the cleanup</a:t>
+            </a:r>
+            <a:endParaRPr lang="en-US" sz="1600" dirty="0"/>
+          </a:p>
+        </p:txBody>
+      </p:sp>
+      <p:sp>
+        <p:nvSpPr>
           <p:cNvPr id="12" name="Text 8"/>
           <p:cNvSpPr txBox="1"/>
           <p:nvPr/>
         </p:nvSpPr>
         <p:spPr>
           <a:xfrm>
-            <a:off x="5326380" y="1965960"/>
-            <a:ext cx="2331720" cy="548640"/>
+            <a:off x="4549140" y="2651760"/>
+            <a:ext cx="3063240" cy="1005840"/>
           </a:xfrm>
           <a:prstGeom prst="rect">
             <a:avLst/>
@@ -13012,49 +13010,13 @@
           <a:ln/>
         </p:spPr>
         <p:txBody>
-          <a:bodyPr wrap="square" lIns="0" tIns="0" rIns="0" bIns="0" rtlCol="0" anchor="ctr"/>
+          <a:bodyPr wrap="square" lIns="0" tIns="0" rIns="0" bIns="0" rtlCol="0" anchor="t"/>
           <a:lstStyle/>
           <a:p>
             <a:pPr indent="0" marL="0">
               <a:buNone/>
             </a:pPr>
             <a:r>
-              <a:rPr lang="en-US" sz="1600" b="1" dirty="0">
-                <a:solidFill>
-                  <a:schemeClr val="bg1"/>
-                </a:solidFill>
-              </a:rPr>
-              <a:t>Fix the cleanup</a:t>
-            </a:r>
-            <a:endParaRPr lang="en-US" sz="1600" dirty="0"/>
-          </a:p>
-        </p:txBody>
-      </p:sp>
-      <p:sp>
-        <p:nvSpPr>
-          <p:cNvPr id="13" name="Text 9"/>
-          <p:cNvSpPr txBox="1"/>
-          <p:nvPr/>
-        </p:nvSpPr>
-        <p:spPr>
-          <a:xfrm>
-            <a:off x="4549140" y="2651760"/>
-            <a:ext cx="3063240" cy="1005840"/>
-          </a:xfrm>
-          <a:prstGeom prst="rect">
-            <a:avLst/>
-          </a:prstGeom>
-          <a:noFill/>
-          <a:ln/>
-        </p:spPr>
-        <p:txBody>
-          <a:bodyPr wrap="square" lIns="0" tIns="0" rIns="0" bIns="0" rtlCol="0" anchor="t"/>
-          <a:lstStyle/>
-          <a:p>
-            <a:pPr indent="0" marL="0">
-              <a:buNone/>
-            </a:pPr>
-            <a:r>
               <a:rPr lang="en-US" sz="1400" dirty="0">
                 <a:solidFill>
                   <a:schemeClr val="bg2"/>
@@ -13068,7 +13030,7 @@
       </p:sp>
       <p:sp>
         <p:nvSpPr>
-          <p:cNvPr id="14" name="change One cutoff per tag"/>
+          <p:cNvPr id="13" name="change One cutoff per tag"/>
           <p:cNvSpPr/>
           <p:nvPr/>
         </p:nvSpPr>
@@ -13092,7 +13054,7 @@
       </p:sp>
       <p:sp>
         <p:nvSpPr>
-          <p:cNvPr id="15" name="icon circle sliders"/>
+          <p:cNvPr id="14" name="icon circle sliders"/>
           <p:cNvSpPr/>
           <p:nvPr/>
         </p:nvSpPr>
@@ -13112,7 +13074,7 @@
       </p:sp>
       <p:pic>
         <p:nvPicPr>
-          <p:cNvPr id="16" name="icon sliders" descr="/tmp/claude-0/-home-claude/8a3a1460-c291-5da5-a3bd-e15a8fc25c88/scratchpad/deck3/icons/sliders.png">    </p:cNvPr>
+          <p:cNvPr id="15" name="icon sliders" descr="Sliders icon">    </p:cNvPr>
           <p:cNvPicPr>
             <a:picLocks noChangeAspect="1"/>
           </p:cNvPicPr>
@@ -13136,14 +13098,50 @@
       </p:pic>
       <p:sp>
         <p:nvSpPr>
+          <p:cNvPr id="16" name="Text 11"/>
+          <p:cNvSpPr txBox="1"/>
+          <p:nvPr/>
+        </p:nvSpPr>
+        <p:spPr>
+          <a:xfrm>
+            <a:off x="9098280" y="1965960"/>
+            <a:ext cx="2331720" cy="548640"/>
+          </a:xfrm>
+          <a:prstGeom prst="rect">
+            <a:avLst/>
+          </a:prstGeom>
+          <a:noFill/>
+          <a:ln/>
+        </p:spPr>
+        <p:txBody>
+          <a:bodyPr wrap="square" lIns="0" tIns="0" rIns="0" bIns="0" rtlCol="0" anchor="ctr"/>
+          <a:lstStyle/>
+          <a:p>
+            <a:pPr indent="0" marL="0">
+              <a:buNone/>
+            </a:pPr>
+            <a:r>
+              <a:rPr lang="en-US" sz="1600" b="1" dirty="0">
+                <a:solidFill>
+                  <a:schemeClr val="bg1"/>
+                </a:solidFill>
+              </a:rPr>
+              <a:t>One cutoff per tag</a:t>
+            </a:r>
+            <a:endParaRPr lang="en-US" sz="1600" dirty="0"/>
+          </a:p>
+        </p:txBody>
+      </p:sp>
+      <p:sp>
+        <p:nvSpPr>
           <p:cNvPr id="17" name="Text 12"/>
           <p:cNvSpPr txBox="1"/>
           <p:nvPr/>
         </p:nvSpPr>
         <p:spPr>
           <a:xfrm>
-            <a:off x="9098280" y="1965960"/>
-            <a:ext cx="2331720" cy="548640"/>
+            <a:off x="8321040" y="2651760"/>
+            <a:ext cx="3063240" cy="1005840"/>
           </a:xfrm>
           <a:prstGeom prst="rect">
             <a:avLst/>
@@ -13152,49 +13150,13 @@
           <a:ln/>
         </p:spPr>
         <p:txBody>
-          <a:bodyPr wrap="square" lIns="0" tIns="0" rIns="0" bIns="0" rtlCol="0" anchor="ctr"/>
+          <a:bodyPr wrap="square" lIns="0" tIns="0" rIns="0" bIns="0" rtlCol="0" anchor="t"/>
           <a:lstStyle/>
           <a:p>
             <a:pPr indent="0" marL="0">
               <a:buNone/>
             </a:pPr>
             <a:r>
-              <a:rPr lang="en-US" sz="1600" b="1" dirty="0">
-                <a:solidFill>
-                  <a:schemeClr val="bg1"/>
-                </a:solidFill>
-              </a:rPr>
-              <a:t>One cutoff per tag</a:t>
-            </a:r>
-            <a:endParaRPr lang="en-US" sz="1600" dirty="0"/>
-          </a:p>
-        </p:txBody>
-      </p:sp>
-      <p:sp>
-        <p:nvSpPr>
-          <p:cNvPr id="18" name="Text 13"/>
-          <p:cNvSpPr txBox="1"/>
-          <p:nvPr/>
-        </p:nvSpPr>
-        <p:spPr>
-          <a:xfrm>
-            <a:off x="8321040" y="2651760"/>
-            <a:ext cx="3063240" cy="1005840"/>
-          </a:xfrm>
-          <a:prstGeom prst="rect">
-            <a:avLst/>
-          </a:prstGeom>
-          <a:noFill/>
-          <a:ln/>
-        </p:spPr>
-        <p:txBody>
-          <a:bodyPr wrap="square" lIns="0" tIns="0" rIns="0" bIns="0" rtlCol="0" anchor="t"/>
-          <a:lstStyle/>
-          <a:p>
-            <a:pPr indent="0" marL="0">
-              <a:buNone/>
-            </a:pPr>
-            <a:r>
               <a:rPr lang="en-US" sz="1400" dirty="0">
                 <a:solidFill>
                   <a:schemeClr val="bg2"/>
@@ -13208,7 +13170,7 @@
       </p:sp>
       <p:sp>
         <p:nvSpPr>
-          <p:cNvPr id="19" name="change Newer data"/>
+          <p:cNvPr id="18" name="change Newer data"/>
           <p:cNvSpPr/>
           <p:nvPr/>
         </p:nvSpPr>
@@ -13232,7 +13194,7 @@
       </p:sp>
       <p:sp>
         <p:nvSpPr>
-          <p:cNvPr id="20" name="icon circle calendar"/>
+          <p:cNvPr id="19" name="icon circle calendar"/>
           <p:cNvSpPr/>
           <p:nvPr/>
         </p:nvSpPr>
@@ -13252,7 +13214,7 @@
       </p:sp>
       <p:pic>
         <p:nvPicPr>
-          <p:cNvPr id="21" name="icon calendar" descr="/tmp/claude-0/-home-claude/8a3a1460-c291-5da5-a3bd-e15a8fc25c88/scratchpad/deck3/icons/calendar.png">    </p:cNvPr>
+          <p:cNvPr id="20" name="icon calendar" descr="Calendar icon">    </p:cNvPr>
           <p:cNvPicPr>
             <a:picLocks noChangeAspect="1"/>
           </p:cNvPicPr>
@@ -13276,14 +13238,50 @@
       </p:pic>
       <p:sp>
         <p:nvSpPr>
+          <p:cNvPr id="21" name="Text 15"/>
+          <p:cNvSpPr txBox="1"/>
+          <p:nvPr/>
+        </p:nvSpPr>
+        <p:spPr>
+          <a:xfrm>
+            <a:off x="3440430" y="4297680"/>
+            <a:ext cx="2331720" cy="548640"/>
+          </a:xfrm>
+          <a:prstGeom prst="rect">
+            <a:avLst/>
+          </a:prstGeom>
+          <a:noFill/>
+          <a:ln/>
+        </p:spPr>
+        <p:txBody>
+          <a:bodyPr wrap="square" lIns="0" tIns="0" rIns="0" bIns="0" rtlCol="0" anchor="ctr"/>
+          <a:lstStyle/>
+          <a:p>
+            <a:pPr indent="0" marL="0">
+              <a:buNone/>
+            </a:pPr>
+            <a:r>
+              <a:rPr lang="en-US" sz="1600" b="1" dirty="0">
+                <a:solidFill>
+                  <a:schemeClr val="bg1"/>
+                </a:solidFill>
+              </a:rPr>
+              <a:t>Newer data</a:t>
+            </a:r>
+            <a:endParaRPr lang="en-US" sz="1600" dirty="0"/>
+          </a:p>
+        </p:txBody>
+      </p:sp>
+      <p:sp>
+        <p:nvSpPr>
           <p:cNvPr id="22" name="Text 16"/>
           <p:cNvSpPr txBox="1"/>
           <p:nvPr/>
         </p:nvSpPr>
         <p:spPr>
           <a:xfrm>
-            <a:off x="3440430" y="4297680"/>
-            <a:ext cx="2331720" cy="548640"/>
+            <a:off x="2663190" y="4983480"/>
+            <a:ext cx="3063240" cy="1005840"/>
           </a:xfrm>
           <a:prstGeom prst="rect">
             <a:avLst/>
@@ -13292,49 +13290,13 @@
           <a:ln/>
         </p:spPr>
         <p:txBody>
-          <a:bodyPr wrap="square" lIns="0" tIns="0" rIns="0" bIns="0" rtlCol="0" anchor="ctr"/>
+          <a:bodyPr wrap="square" lIns="0" tIns="0" rIns="0" bIns="0" rtlCol="0" anchor="t"/>
           <a:lstStyle/>
           <a:p>
             <a:pPr indent="0" marL="0">
               <a:buNone/>
             </a:pPr>
             <a:r>
-              <a:rPr lang="en-US" sz="1600" b="1" dirty="0">
-                <a:solidFill>
-                  <a:schemeClr val="bg1"/>
-                </a:solidFill>
-              </a:rPr>
-              <a:t>Newer data</a:t>
-            </a:r>
-            <a:endParaRPr lang="en-US" sz="1600" dirty="0"/>
-          </a:p>
-        </p:txBody>
-      </p:sp>
-      <p:sp>
-        <p:nvSpPr>
-          <p:cNvPr id="23" name="Text 17"/>
-          <p:cNvSpPr txBox="1"/>
-          <p:nvPr/>
-        </p:nvSpPr>
-        <p:spPr>
-          <a:xfrm>
-            <a:off x="2663190" y="4983480"/>
-            <a:ext cx="3063240" cy="1005840"/>
-          </a:xfrm>
-          <a:prstGeom prst="rect">
-            <a:avLst/>
-          </a:prstGeom>
-          <a:noFill/>
-          <a:ln/>
-        </p:spPr>
-        <p:txBody>
-          <a:bodyPr wrap="square" lIns="0" tIns="0" rIns="0" bIns="0" rtlCol="0" anchor="t"/>
-          <a:lstStyle/>
-          <a:p>
-            <a:pPr indent="0" marL="0">
-              <a:buNone/>
-            </a:pPr>
-            <a:r>
               <a:rPr lang="en-US" sz="1400" dirty="0">
                 <a:solidFill>
                   <a:schemeClr val="bg2"/>
@@ -13348,7 +13310,7 @@
       </p:sp>
       <p:sp>
         <p:nvSpPr>
-          <p:cNvPr id="24" name="change More tags"/>
+          <p:cNvPr id="23" name="change More tags"/>
           <p:cNvSpPr/>
           <p:nvPr/>
         </p:nvSpPr>
@@ -13372,7 +13334,7 @@
       </p:sp>
       <p:sp>
         <p:nvSpPr>
-          <p:cNvPr id="25" name="icon circle tags"/>
+          <p:cNvPr id="24" name="icon circle tags"/>
           <p:cNvSpPr/>
           <p:nvPr/>
         </p:nvSpPr>
@@ -13392,7 +13354,7 @@
       </p:sp>
       <p:pic>
         <p:nvPicPr>
-          <p:cNvPr id="26" name="icon tags" descr="/tmp/claude-0/-home-claude/8a3a1460-c291-5da5-a3bd-e15a8fc25c88/scratchpad/deck3/icons/tags.png">    </p:cNvPr>
+          <p:cNvPr id="25" name="icon tags" descr="Tags icon">    </p:cNvPr>
           <p:cNvPicPr>
             <a:picLocks noChangeAspect="1"/>
           </p:cNvPicPr>
@@ -13416,14 +13378,50 @@
       </p:pic>
       <p:sp>
         <p:nvSpPr>
+          <p:cNvPr id="26" name="Text 19"/>
+          <p:cNvSpPr txBox="1"/>
+          <p:nvPr/>
+        </p:nvSpPr>
+        <p:spPr>
+          <a:xfrm>
+            <a:off x="7212330" y="4297680"/>
+            <a:ext cx="2331720" cy="548640"/>
+          </a:xfrm>
+          <a:prstGeom prst="rect">
+            <a:avLst/>
+          </a:prstGeom>
+          <a:noFill/>
+          <a:ln/>
+        </p:spPr>
+        <p:txBody>
+          <a:bodyPr wrap="square" lIns="0" tIns="0" rIns="0" bIns="0" rtlCol="0" anchor="ctr"/>
+          <a:lstStyle/>
+          <a:p>
+            <a:pPr indent="0" marL="0">
+              <a:buNone/>
+            </a:pPr>
+            <a:r>
+              <a:rPr lang="en-US" sz="1600" b="1" dirty="0">
+                <a:solidFill>
+                  <a:schemeClr val="bg1"/>
+                </a:solidFill>
+              </a:rPr>
+              <a:t>More tags</a:t>
+            </a:r>
+            <a:endParaRPr lang="en-US" sz="1600" dirty="0"/>
+          </a:p>
+        </p:txBody>
+      </p:sp>
+      <p:sp>
+        <p:nvSpPr>
           <p:cNvPr id="27" name="Text 20"/>
           <p:cNvSpPr txBox="1"/>
           <p:nvPr/>
         </p:nvSpPr>
         <p:spPr>
           <a:xfrm>
-            <a:off x="7212330" y="4297680"/>
-            <a:ext cx="2331720" cy="548640"/>
+            <a:off x="6435090" y="4983480"/>
+            <a:ext cx="3063240" cy="1005840"/>
           </a:xfrm>
           <a:prstGeom prst="rect">
             <a:avLst/>
@@ -13432,21 +13430,21 @@
           <a:ln/>
         </p:spPr>
         <p:txBody>
-          <a:bodyPr wrap="square" lIns="0" tIns="0" rIns="0" bIns="0" rtlCol="0" anchor="ctr"/>
+          <a:bodyPr wrap="square" lIns="0" tIns="0" rIns="0" bIns="0" rtlCol="0" anchor="t"/>
           <a:lstStyle/>
           <a:p>
             <a:pPr indent="0" marL="0">
               <a:buNone/>
             </a:pPr>
             <a:r>
-              <a:rPr lang="en-US" sz="1600" b="1" dirty="0">
-                <a:solidFill>
-                  <a:schemeClr val="bg1"/>
-                </a:solidFill>
-              </a:rPr>
-              <a:t>More tags</a:t>
-            </a:r>
-            <a:endParaRPr lang="en-US" sz="1600" dirty="0"/>
+              <a:rPr lang="en-US" sz="1400" dirty="0">
+                <a:solidFill>
+                  <a:schemeClr val="bg2"/>
+                </a:solidFill>
+              </a:rPr>
+              <a:t>Only the 100 most common tags were modeled; 6,784 were left out.</a:t>
+            </a:r>
+            <a:endParaRPr lang="en-US" sz="1400" dirty="0"/>
           </a:p>
         </p:txBody>
       </p:sp>
@@ -13458,8 +13456,8 @@
         </p:nvSpPr>
         <p:spPr>
           <a:xfrm>
-            <a:off x="6435090" y="4983480"/>
-            <a:ext cx="3063240" cy="1005840"/>
+            <a:off x="548640" y="6309360"/>
+            <a:ext cx="10424160" cy="320040"/>
           </a:xfrm>
           <a:prstGeom prst="rect">
             <a:avLst/>
@@ -13475,27 +13473,29 @@
               <a:buNone/>
             </a:pPr>
             <a:r>
-              <a:rPr lang="en-US" sz="1400" dirty="0">
+              <a:rPr lang="en-US" sz="1200" dirty="0">
                 <a:solidFill>
                   <a:schemeClr val="bg2"/>
                 </a:solidFill>
               </a:rPr>
-              <a:t>Only the 100 most common tags were modeled; 6,784 were left out.</a:t>
-            </a:r>
-            <a:endParaRPr lang="en-US" sz="1400" dirty="0"/>
-          </a:p>
-        </p:txBody>
-      </p:sp>
-      <p:sp>
-        <p:nvSpPr>
-          <p:cNvPr id="29" name="Text 22"/>
-          <p:cNvSpPr txBox="1"/>
-          <p:nvPr/>
-        </p:nvSpPr>
-        <p:spPr>
-          <a:xfrm>
-            <a:off x="548640" y="6309360"/>
-            <a:ext cx="10424160" cy="320040"/>
+              <a:t>Code, notebook and these slides: github.com/garrethcline/Predicting-Tags-from-StackOverflow-Using-Title-Data-</a:t>
+            </a:r>
+            <a:endParaRPr lang="en-US" sz="1200" dirty="0"/>
+          </a:p>
+        </p:txBody>
+      </p:sp>
+      <p:sp>
+        <p:nvSpPr>
+          <p:cNvPr id="29" name="Text 0"/>
+          <p:cNvSpPr/>
+          <p:nvPr>
+            <p:ph idx="101" type="body" hasCustomPrompt="1"/>
+          </p:nvPr>
+        </p:nvSpPr>
+        <p:spPr>
+          <a:xfrm>
+            <a:off x="548640" y="987552"/>
+            <a:ext cx="11064240" cy="411480"/>
           </a:xfrm>
           <a:prstGeom prst="rect">
             <a:avLst/>
@@ -13504,21 +13504,13 @@
           <a:ln/>
         </p:spPr>
         <p:txBody>
-          <a:bodyPr wrap="square" lIns="0" tIns="0" rIns="0" bIns="0" rtlCol="0" anchor="t"/>
-          <a:lstStyle/>
-          <a:p>
-            <a:pPr indent="0" marL="0">
-              <a:buNone/>
-            </a:pPr>
-            <a:r>
-              <a:rPr lang="en-US" sz="1200" dirty="0">
-                <a:solidFill>
-                  <a:schemeClr val="bg2"/>
-                </a:solidFill>
-              </a:rPr>
-              <a:t>Code, notebook and these slides: github.com/garrethcline/Predicting-Tags-from-StackOverflow-Using-Title-Data-</a:t>
-            </a:r>
-            <a:endParaRPr lang="en-US" sz="1200" dirty="0"/>
+          <a:bodyPr wrap="square" lIns="0" tIns="0" rIns="0" bIns="0" rtlCol="0" anchor="ctr"/>
+          <a:lstStyle/>
+          <a:p>
+            <a:pPr algn="l" indent="0" marL="0">
+              <a:buNone/>
+            </a:pPr>
+            <a:endParaRPr lang="en-US" sz="1600" dirty="0"/>
           </a:p>
         </p:txBody>
       </p:sp>
@@ -13690,7 +13682,7 @@
       </p:sp>
       <p:pic>
         <p:nvPicPr>
-          <p:cNvPr id="5" name="icon pen" descr="/tmp/claude-0/-home-claude/8a3a1460-c291-5da5-a3bd-e15a8fc25c88/scratchpad/deck3/icons/pen.png">    </p:cNvPr>
+          <p:cNvPr id="5" name="icon pen" descr="Pencil icon">    </p:cNvPr>
           <p:cNvPicPr>
             <a:picLocks noChangeAspect="1"/>
           </p:cNvPicPr>
@@ -13778,7 +13770,7 @@
                   <a:schemeClr val="accent6"/>
                 </a:solidFill>
               </a:rPr>
-              <a:t>Recommend tags while a question is still being written.</a:t>
+              <a:t>The title is the first thing people type, so suggestions could show up before the body is started.</a:t>
             </a:r>
             <a:endParaRPr lang="en-US" sz="1400" dirty="0"/>
           </a:p>
@@ -13806,7 +13798,7 @@
       </p:sp>
       <p:pic>
         <p:nvPicPr>
-          <p:cNvPr id="9" name="icon archive" descr="/tmp/claude-0/-home-claude/8a3a1460-c291-5da5-a3bd-e15a8fc25c88/scratchpad/deck3/icons/archive.png">    </p:cNvPr>
+          <p:cNvPr id="9" name="icon archive" descr="Archive box icon">    </p:cNvPr>
           <p:cNvPicPr>
             <a:picLocks noChangeAspect="1"/>
           </p:cNvPicPr>
@@ -13894,7 +13886,7 @@
                   <a:schemeClr val="accent6"/>
                 </a:solidFill>
               </a:rPr>
-              <a:t>Add tags to posts or other text that has none.</a:t>
+              <a:t>Run the same model over text that never had tags, like old forum posts.</a:t>
             </a:r>
             <a:endParaRPr lang="en-US" sz="1400" dirty="0"/>
           </a:p>
@@ -13922,7 +13914,7 @@
       </p:sp>
       <p:pic>
         <p:nvPicPr>
-          <p:cNvPr id="13" name="icon tags" descr="/tmp/claude-0/-home-claude/8a3a1460-c291-5da5-a3bd-e15a8fc25c88/scratchpad/deck3/icons/tags.png">    </p:cNvPr>
+          <p:cNvPr id="13" name="icon tags" descr="Tags icon">    </p:cNvPr>
           <p:cNvPicPr>
             <a:picLocks noChangeAspect="1"/>
           </p:cNvPicPr>
@@ -16618,7 +16610,7 @@
       </p:sp>
       <p:pic>
         <p:nvPicPr>
-          <p:cNvPr id="5" name="icon archive" descr="/tmp/claude-0/-home-claude/8a3a1460-c291-5da5-a3bd-e15a8fc25c88/scratchpad/deck3/icons/archive.png">    </p:cNvPr>
+          <p:cNvPr id="5" name="icon archive" descr="Archive box icon">    </p:cNvPr>
           <p:cNvPicPr>
             <a:picLocks noChangeAspect="1"/>
           </p:cNvPicPr>
@@ -16758,7 +16750,7 @@
       </p:sp>
       <p:pic>
         <p:nvPicPr>
-          <p:cNvPr id="10" name="icon database" descr="/tmp/claude-0/-home-claude/8a3a1460-c291-5da5-a3bd-e15a8fc25c88/scratchpad/deck3/icons/database.png">    </p:cNvPr>
+          <p:cNvPr id="10" name="icon database" descr="Database icon">    </p:cNvPr>
           <p:cNvPicPr>
             <a:picLocks noChangeAspect="1"/>
           </p:cNvPicPr>
@@ -16898,7 +16890,7 @@
       </p:sp>
       <p:pic>
         <p:nvPicPr>
-          <p:cNvPr id="15" name="icon csv" descr="/tmp/claude-0/-home-claude/8a3a1460-c291-5da5-a3bd-e15a8fc25c88/scratchpad/deck3/icons/csv.png">    </p:cNvPr>
+          <p:cNvPr id="15" name="icon csv" descr="CSV file icon">    </p:cNvPr>
           <p:cNvPicPr>
             <a:picLocks noChangeAspect="1"/>
           </p:cNvPicPr>
@@ -17038,7 +17030,7 @@
       </p:sp>
       <p:pic>
         <p:nvPicPr>
-          <p:cNvPr id="20" name="icon python" descr="/tmp/claude-0/-home-claude/8a3a1460-c291-5da5-a3bd-e15a8fc25c88/scratchpad/deck3/icons/python.png">    </p:cNvPr>
+          <p:cNvPr id="20" name="icon python" descr="Python icon">    </p:cNvPr>
           <p:cNvPicPr>
             <a:picLocks noChangeAspect="1"/>
           </p:cNvPicPr>
@@ -19102,7 +19094,7 @@
       </p:sp>
       <p:sp>
         <p:nvSpPr>
-          <p:cNvPr id="9" name="stat of questions have c#"/>
+          <p:cNvPr id="9" name="stat of test questions have c#"/>
           <p:cNvSpPr/>
           <p:nvPr/>
         </p:nvSpPr>
@@ -19188,7 +19180,7 @@
                   <a:schemeClr val="tx1"/>
                 </a:solidFill>
               </a:rPr>
-              <a:t>of questions have c#</a:t>
+              <a:t>of test questions have c#</a:t>
             </a:r>
             <a:endParaRPr lang="en-US" sz="1500" dirty="0"/>
           </a:p>
@@ -19232,7 +19224,7 @@
       </p:sp>
       <p:sp>
         <p:nvSpPr>
-          <p:cNvPr id="13" name="stat have parsing"/>
+          <p:cNvPr id="13" name="stat test questions have parsing"/>
           <p:cNvSpPr/>
           <p:nvPr/>
         </p:nvSpPr>
@@ -19318,7 +19310,7 @@
                   <a:schemeClr val="tx1"/>
                 </a:solidFill>
               </a:rPr>
-              <a:t>have parsing</a:t>
+              <a:t>test questions have parsing</a:t>
             </a:r>
             <a:endParaRPr lang="en-US" sz="1500" dirty="0"/>
           </a:p>
@@ -19354,7 +19346,7 @@
                   <a:schemeClr val="accent6"/>
                 </a:solidFill>
               </a:rPr>
-              <a:t>the least common of the 100</a:t>
+              <a:t>the fewest of the 100 tags</a:t>
             </a:r>
             <a:endParaRPr lang="en-US" sz="1300" dirty="0"/>
           </a:p>
@@ -20510,23 +20502,12 @@
               <a:buNone/>
             </a:pPr>
             <a:r>
-              <a:rPr lang="en-US" sz="1400" b="1" dirty="0">
+              <a:rPr lang="en-US" sz="1400" dirty="0">
                 <a:solidFill>
                   <a:schemeClr val="tx1"/>
                 </a:solidFill>
               </a:rPr>
-              <a:t>Something I noticed in 2026: </a:t>
-            </a:r>
-            <a:pPr indent="0" marL="0">
-              <a:buNone/>
-            </a:pPr>
-            <a:r>
-              <a:rPr lang="en-US" sz="1400" dirty="0">
-                <a:solidFill>
-                  <a:schemeClr val="tx1"/>
-                </a:solidFill>
-              </a:rPr>
-              <a:t>capitalized common words like “How” got through, because the common-word filter only matched lower case.</a:t>
+              <a:t>In 2026 I noticed that capitalized common words like “How” got through, because the common-word filter only matched lower case.</a:t>
             </a:r>
             <a:endParaRPr lang="en-US" sz="1400" dirty="0"/>
           </a:p>

</xml_diff>